<commit_message>
docs(024): the demo video's link, and a QR code for each of the three links
The video is public at https://youtu.be/5UI2NZFmzrk. Slide 15 of the deck shows the live app, the
repository and the video, each with a QR code; the app's code opened the mirror and now opens
kredibel.app, as printed beside it. The codes are in docs/submission/qr as SVG and PNG. The README,
the form answers and the submission pack carry the video link.

Tasks: T024-09
AC: AC-024-1
</commit_message>
<xml_diff>
--- a/docs/submission/kredibel-pitch-deck.pptx
+++ b/docs/submission/kredibel-pitch-deck.pptx
@@ -20705,7 +20705,7 @@
           <p:nvPr/>
         </p:nvPicPr>
         <p:blipFill rotWithShape="1">
-          <a:blip r:embed="rId6">
+          <a:blip r:embed="rId9">
             <a:alphaModFix/>
           </a:blip>
           <a:srcRect b="0" l="0" r="0" t="0"/>
@@ -20866,6 +20866,60 @@
       </p:sp>
       <p:sp>
         <p:nvSpPr>
+          <p:cNvPr id="716" name="Google Shape;707;p15"/>
+          <p:cNvSpPr txBox="1"/>
+          <p:nvPr/>
+        </p:nvSpPr>
+        <p:spPr>
+          <a:xfrm>
+            <a:off x="2423160" y="3611880"/>
+            <a:ext cx="4754880" cy="274320"/>
+          </a:xfrm>
+          <a:prstGeom prst="rect">
+            <a:avLst/>
+          </a:prstGeom>
+          <a:noFill/>
+          <a:ln>
+            <a:noFill/>
+          </a:ln>
+        </p:spPr>
+        <p:txBody>
+          <a:bodyPr anchorCtr="0" anchor="t" bIns="0" lIns="0" spcFirstLastPara="1" rIns="0" wrap="square" tIns="0">
+            <a:noAutofit/>
+          </a:bodyPr>
+          <a:lstStyle/>
+          <a:p>
+            <a:pPr indent="0" lvl="0" marL="0" marR="0" rtl="0" algn="l">
+              <a:lnSpc>
+                <a:spcPct val="100000"/>
+              </a:lnSpc>
+              <a:spcBef>
+                <a:spcPts val="0"/>
+              </a:spcBef>
+              <a:spcAft>
+                <a:spcPts val="0"/>
+              </a:spcAft>
+              <a:buNone/>
+            </a:pPr>
+            <a:r>
+              <a:rPr b="1" i="0" lang="en-US" sz="1250" u="sng" cap="none" strike="noStrike">
+                <a:solidFill>
+                  <a:srgbClr val="0E5A47"/>
+                </a:solidFill>
+                <a:latin typeface="Archivo"/>
+                <a:ea typeface="Archivo"/>
+                <a:cs typeface="Archivo"/>
+                <a:sym typeface="Archivo"/>
+                <a:hlinkClick r:id="rId10"/>
+              </a:rPr>
+              <a:t>https://youtu.be/5UI2NZFmzrk</a:t>
+            </a:r>
+            <a:endParaRPr/>
+          </a:p>
+        </p:txBody>
+      </p:sp>
+      <p:sp>
+        <p:nvSpPr>
           <p:cNvPr id="708" name="Google Shape;708;p15"/>
           <p:cNvSpPr txBox="1"/>
           <p:nvPr/>
@@ -20944,6 +20998,33 @@
           </a:ln>
         </p:spPr>
       </p:pic>
+      <p:pic>
+        <p:nvPicPr>
+          <p:cNvPr descr="qr_gh.png" id="717" name="Google Shape;709;p15"/>
+          <p:cNvPicPr preferRelativeResize="0"/>
+          <p:nvPr/>
+        </p:nvPicPr>
+        <p:blipFill rotWithShape="1">
+          <a:blip r:embed="rId11">
+            <a:alphaModFix/>
+          </a:blip>
+          <a:srcRect b="0" l="0" r="0" t="0"/>
+          <a:stretch/>
+        </p:blipFill>
+        <p:spPr>
+          <a:xfrm>
+            <a:off x="7982712" y="3602737"/>
+            <a:ext cx="749808" cy="749808"/>
+          </a:xfrm>
+          <a:prstGeom prst="rect">
+            <a:avLst/>
+          </a:prstGeom>
+          <a:noFill/>
+          <a:ln>
+            <a:noFill/>
+          </a:ln>
+        </p:spPr>
+      </p:pic>
       <p:cxnSp>
         <p:nvCxnSpPr>
           <p:cNvPr id="710" name="Google Shape;710;p15"/>
@@ -21025,121 +21106,6 @@
       </p:sp>
       <p:sp>
         <p:nvSpPr>
-          <p:cNvPr id="712" name="Google Shape;712;p15"/>
-          <p:cNvSpPr/>
-          <p:nvPr/>
-        </p:nvSpPr>
-        <p:spPr>
-          <a:xfrm>
-            <a:off x="2423160" y="3593592"/>
-            <a:ext cx="2011680" cy="274320"/>
-          </a:xfrm>
-          <a:prstGeom prst="roundRect">
-            <a:avLst>
-              <a:gd fmla="val 16666" name="adj"/>
-            </a:avLst>
-          </a:prstGeom>
-          <a:solidFill>
-            <a:srgbClr val="F1EEFF"/>
-          </a:solidFill>
-          <a:ln cap="flat" cmpd="sng" w="9525">
-            <a:solidFill>
-              <a:srgbClr val="A99BFF"/>
-            </a:solidFill>
-            <a:prstDash val="dash"/>
-            <a:round/>
-            <a:headEnd len="sm" w="sm" type="none"/>
-            <a:tailEnd len="sm" w="sm" type="none"/>
-          </a:ln>
-        </p:spPr>
-        <p:txBody>
-          <a:bodyPr anchorCtr="0" anchor="ctr" bIns="0" lIns="0" spcFirstLastPara="1" rIns="0" wrap="square" tIns="0">
-            <a:noAutofit/>
-          </a:bodyPr>
-          <a:lstStyle/>
-          <a:p>
-            <a:pPr indent="0" lvl="0" marL="0" marR="0" rtl="0" algn="ctr">
-              <a:lnSpc>
-                <a:spcPct val="100000"/>
-              </a:lnSpc>
-              <a:spcBef>
-                <a:spcPts val="0"/>
-              </a:spcBef>
-              <a:spcAft>
-                <a:spcPts val="0"/>
-              </a:spcAft>
-              <a:buNone/>
-            </a:pPr>
-            <a:r>
-              <a:t/>
-            </a:r>
-            <a:endParaRPr b="0" i="0" sz="1400" u="none" cap="none" strike="noStrike">
-              <a:solidFill>
-                <a:srgbClr val="000000"/>
-              </a:solidFill>
-              <a:latin typeface="Arial"/>
-              <a:ea typeface="Arial"/>
-              <a:cs typeface="Arial"/>
-              <a:sym typeface="Arial"/>
-            </a:endParaRPr>
-          </a:p>
-        </p:txBody>
-      </p:sp>
-      <p:sp>
-        <p:nvSpPr>
-          <p:cNvPr id="713" name="Google Shape;713;p15"/>
-          <p:cNvSpPr txBox="1"/>
-          <p:nvPr/>
-        </p:nvSpPr>
-        <p:spPr>
-          <a:xfrm>
-            <a:off x="2514600" y="3630168"/>
-            <a:ext cx="1920240" cy="228600"/>
-          </a:xfrm>
-          <a:prstGeom prst="rect">
-            <a:avLst/>
-          </a:prstGeom>
-          <a:noFill/>
-          <a:ln>
-            <a:noFill/>
-          </a:ln>
-        </p:spPr>
-        <p:txBody>
-          <a:bodyPr anchorCtr="0" anchor="t" bIns="0" lIns="0" spcFirstLastPara="1" rIns="0" wrap="square" tIns="0">
-            <a:noAutofit/>
-          </a:bodyPr>
-          <a:lstStyle/>
-          <a:p>
-            <a:pPr indent="0" lvl="0" marL="0" marR="0" rtl="0" algn="l">
-              <a:lnSpc>
-                <a:spcPct val="100000"/>
-              </a:lnSpc>
-              <a:spcBef>
-                <a:spcPts val="0"/>
-              </a:spcBef>
-              <a:spcAft>
-                <a:spcPts val="0"/>
-              </a:spcAft>
-              <a:buNone/>
-            </a:pPr>
-            <a:r>
-              <a:rPr b="0" i="0" lang="en-US" sz="1050" u="none" cap="none" strike="noStrike">
-                <a:solidFill>
-                  <a:srgbClr val="4A2FCC"/>
-                </a:solidFill>
-                <a:latin typeface="Archivo Medium"/>
-                <a:ea typeface="Archivo Medium"/>
-                <a:cs typeface="Archivo Medium"/>
-                <a:sym typeface="Archivo Medium"/>
-              </a:rPr>
-              <a:t>Add video link</a:t>
-            </a:r>
-            <a:endParaRPr/>
-          </a:p>
-        </p:txBody>
-      </p:sp>
-      <p:sp>
-        <p:nvSpPr>
           <p:cNvPr id="714" name="Google Shape;714;p15"/>
           <p:cNvSpPr txBox="1"/>
           <p:nvPr/>
@@ -21185,7 +21151,7 @@
                 <a:cs typeface="Archivo"/>
                 <a:sym typeface="Archivo"/>
               </a:rPr>
-              <a:t>Add the public video link before sending.</a:t>
+              <a:t>The working prototype on production, recorded with the demo account.</a:t>
             </a:r>
             <a:endParaRPr/>
           </a:p>

</xml_diff>